<commit_message>
Integra Traccar para GPS propio
</commit_message>
<xml_diff>
--- a/Fase 1/Evidencias Grupales/PerfilMedico_ExposicionFase1.pptx
+++ b/Fase 1/Evidencias Grupales/PerfilMedico_ExposicionFase1.pptx
@@ -2922,7 +2922,7 @@
                 <a:ea typeface="Calibri" pitchFamily="34" charset="-122"/>
                 <a:cs typeface="Calibri" pitchFamily="34" charset="-120"/>
               </a:rPr>
-              <a:t>GPS con geocercas: alerta si el niño no llega al colegio o el adulto mayor sale de una zona segura</a:t>
+              <a:t>GPS con geocercas vía servidor propio (Traccar, open source): sin depender de la app cerrada del fabricante</a:t>
             </a:r>
             <a:endParaRPr lang="en-US" sz="1300" dirty="0"/>
           </a:p>
@@ -9659,7 +9659,7 @@
                 <a:ea typeface="Calibri" pitchFamily="34" charset="-122"/>
                 <a:cs typeface="Calibri" pitchFamily="34" charset="-120"/>
               </a:rPr>
-              <a:t>$2.990-$3.990 / mes</a:t>
+              <a:t>$3.490 / mes (1er perfil)</a:t>
             </a:r>
             <a:endParaRPr lang="en-US" sz="1300" dirty="0"/>
           </a:p>
@@ -9705,7 +9705,7 @@
                 <a:ea typeface="Calibri" pitchFamily="34" charset="-122"/>
                 <a:cs typeface="Calibri" pitchFamily="34" charset="-120"/>
               </a:rPr>
-              <a:t>Perfiles dependientes ilimitados</a:t>
+              <a:t>Pulsera inteligente conectada (GPS, salud, seguridad)</a:t>
             </a:r>
             <a:endParaRPr lang="en-US" sz="1250" dirty="0"/>
           </a:p>
@@ -9729,7 +9729,7 @@
                 <a:ea typeface="Calibri" pitchFamily="34" charset="-122"/>
                 <a:cs typeface="Calibri" pitchFamily="34" charset="-120"/>
               </a:rPr>
-              <a:t>Pulsera inteligente conectada (GPS, salud, seguridad)</a:t>
+              <a:t>Alertas escalonadas al cuidador</a:t>
             </a:r>
             <a:endParaRPr lang="en-US" sz="1250" dirty="0"/>
           </a:p>
@@ -9753,7 +9753,7 @@
                 <a:ea typeface="Calibri" pitchFamily="34" charset="-122"/>
                 <a:cs typeface="Calibri" pitchFamily="34" charset="-120"/>
               </a:rPr>
-              <a:t>Alertas escalonadas al cuidador</a:t>
+              <a:t>Historial completo + reportes para el médico</a:t>
             </a:r>
             <a:endParaRPr lang="en-US" sz="1250" dirty="0"/>
           </a:p>
@@ -9777,7 +9777,7 @@
                 <a:ea typeface="Calibri" pitchFamily="34" charset="-122"/>
                 <a:cs typeface="Calibri" pitchFamily="34" charset="-120"/>
               </a:rPr>
-              <a:t>Historial completo + reportes para el médico</a:t>
+              <a:t>Módulo de IA (orientación + farmacias)</a:t>
             </a:r>
             <a:endParaRPr lang="en-US" sz="1250" dirty="0"/>
           </a:p>
@@ -9801,7 +9801,7 @@
                 <a:ea typeface="Calibri" pitchFamily="34" charset="-122"/>
                 <a:cs typeface="Calibri" pitchFamily="34" charset="-120"/>
               </a:rPr>
-              <a:t>Módulo de IA (orientación + farmacias)</a:t>
+              <a:t>Cada perfil adicional: 5% de descuento</a:t>
             </a:r>
             <a:endParaRPr lang="en-US" sz="1250" dirty="0"/>
           </a:p>
@@ -9816,7 +9816,7 @@
         <p:spPr>
           <a:xfrm>
             <a:off x="548640" y="6263640"/>
-            <a:ext cx="11064240" cy="320040"/>
+            <a:ext cx="11064240" cy="411480"/>
           </a:xfrm>
           <a:prstGeom prst="rect">
             <a:avLst/>
@@ -9840,7 +9840,7 @@
                 <a:ea typeface="Calibri" pitchFamily="34" charset="-122"/>
                 <a:cs typeface="Calibri" pitchFamily="34" charset="-120"/>
               </a:rPr>
-              <a:t>Plan anual: $24.990-$29.990 CLP (equivalente a ~2 meses gratis frente al pago mensual).</a:t>
+              <a:t>Plan anual: $29.990 CLP (primer perfil). Segundo perfil dependiente en la misma cuenta: ~$3.315/mes (5% de descuento), y así por cada persona extra a cuidar.</a:t>
             </a:r>
             <a:endParaRPr lang="en-US" sz="1050" dirty="0"/>
           </a:p>

</xml_diff>